<commit_message>
feat: add architecture diagram (SVG+PNG), yoga deck v2, gen_arch_diagram v2 with professional layout
- assets/architecture_diagram.svg: polished SVG with gradients, glow filters, diamond nodes
- assets/architecture_diagram.png: raster export for PPTX embedding (via matplotlib)
- scripts/gen_arch_diagram.py: rewritten v2 — evenly-spaced nodes, no floating side boxes, formula inline
- scripts/build_yoga_deck.py: dark yoga-earth theme deck (v1)
- scripts/build_yoga_deck_v2.py: DevBridge light pastel theme deck, 10 slides, embeds screenshots + arch diagram
- scripts/record_demo.py, run_demo_video.sh: demo recording helpers
- app/services/studio_agent.py: new studio agent service
- various app/frontend/pitch updates
</commit_message>
<xml_diff>
--- a/pitch/aeogeo_pitch_deck_ko.pptx
+++ b/pitch/aeogeo_pitch_deck_ko.pptx
@@ -7748,7 +7748,7 @@
       </p:sp>
       <p:pic>
         <p:nvPicPr>
-          <p:cNvPr id="6" name="Picture 5" descr="shot_04_ranked.png"/>
+          <p:cNvPr id="6" name="Picture 5" descr="shot_03_typing.png"/>
           <p:cNvPicPr>
             <a:picLocks noChangeAspect="1"/>
           </p:cNvPicPr>
@@ -7763,7 +7763,7 @@
         <p:spPr>
           <a:xfrm>
             <a:off x="548640" y="1920240"/>
-            <a:ext cx="6949440" cy="3909060"/>
+            <a:ext cx="3429000" cy="1928812"/>
           </a:xfrm>
           <a:prstGeom prst="rect">
             <a:avLst/>
@@ -7773,6 +7773,218 @@
       <p:sp>
         <p:nvSpPr>
           <p:cNvPr id="7" name="TextBox 6"/>
+          <p:cNvSpPr txBox="1"/>
+          <p:nvPr/>
+        </p:nvSpPr>
+        <p:spPr>
+          <a:xfrm>
+            <a:off x="548640" y="3885628"/>
+            <a:ext cx="3429000" cy="201168"/>
+          </a:xfrm>
+          <a:prstGeom prst="rect">
+            <a:avLst/>
+          </a:prstGeom>
+          <a:noFill/>
+        </p:spPr>
+        <p:txBody>
+          <a:bodyPr wrap="square" anchor="t" lIns="0" rIns="0" tIns="0" bIns="0">
+            <a:spAutoFit/>
+          </a:bodyPr>
+          <a:lstStyle/>
+          <a:p>
+            <a:pPr algn="ctr"/>
+            <a:r>
+              <a:rPr sz="1000" b="0">
+                <a:solidFill>
+                  <a:srgbClr val="8B97AA"/>
+                </a:solidFill>
+                <a:latin typeface="Pretendard"/>
+              </a:rPr>
+              <a:t>① 목표·조건 입력</a:t>
+            </a:r>
+          </a:p>
+        </p:txBody>
+      </p:sp>
+      <p:pic>
+        <p:nvPicPr>
+          <p:cNvPr id="8" name="Picture 7" descr="shot_04_ranked.png"/>
+          <p:cNvPicPr>
+            <a:picLocks noChangeAspect="1"/>
+          </p:cNvPicPr>
+          <p:nvPr/>
+        </p:nvPicPr>
+        <p:blipFill>
+          <a:blip r:embed="rId3"/>
+          <a:stretch>
+            <a:fillRect/>
+          </a:stretch>
+        </p:blipFill>
+        <p:spPr>
+          <a:xfrm>
+            <a:off x="4069080" y="1920240"/>
+            <a:ext cx="3429000" cy="1928812"/>
+          </a:xfrm>
+          <a:prstGeom prst="rect">
+            <a:avLst/>
+          </a:prstGeom>
+        </p:spPr>
+      </p:pic>
+      <p:sp>
+        <p:nvSpPr>
+          <p:cNvPr id="9" name="TextBox 8"/>
+          <p:cNvSpPr txBox="1"/>
+          <p:nvPr/>
+        </p:nvSpPr>
+        <p:spPr>
+          <a:xfrm>
+            <a:off x="4069080" y="3885628"/>
+            <a:ext cx="3429000" cy="201168"/>
+          </a:xfrm>
+          <a:prstGeom prst="rect">
+            <a:avLst/>
+          </a:prstGeom>
+          <a:noFill/>
+        </p:spPr>
+        <p:txBody>
+          <a:bodyPr wrap="square" anchor="t" lIns="0" rIns="0" tIns="0" bIns="0">
+            <a:spAutoFit/>
+          </a:bodyPr>
+          <a:lstStyle/>
+          <a:p>
+            <a:pPr algn="ctr"/>
+            <a:r>
+              <a:rPr sz="1000" b="0">
+                <a:solidFill>
+                  <a:srgbClr val="8B97AA"/>
+                </a:solidFill>
+                <a:latin typeface="Pretendard"/>
+              </a:rPr>
+              <a:t>② Top-3 추천</a:t>
+            </a:r>
+          </a:p>
+        </p:txBody>
+      </p:sp>
+      <p:pic>
+        <p:nvPicPr>
+          <p:cNvPr id="10" name="Picture 9" descr="shot_05_breakdown.png"/>
+          <p:cNvPicPr>
+            <a:picLocks noChangeAspect="1"/>
+          </p:cNvPicPr>
+          <p:nvPr/>
+        </p:nvPicPr>
+        <p:blipFill>
+          <a:blip r:embed="rId4"/>
+          <a:stretch>
+            <a:fillRect/>
+          </a:stretch>
+        </p:blipFill>
+        <p:spPr>
+          <a:xfrm>
+            <a:off x="548640" y="4114800"/>
+            <a:ext cx="3429000" cy="1928812"/>
+          </a:xfrm>
+          <a:prstGeom prst="rect">
+            <a:avLst/>
+          </a:prstGeom>
+        </p:spPr>
+      </p:pic>
+      <p:sp>
+        <p:nvSpPr>
+          <p:cNvPr id="11" name="TextBox 10"/>
+          <p:cNvSpPr txBox="1"/>
+          <p:nvPr/>
+        </p:nvSpPr>
+        <p:spPr>
+          <a:xfrm>
+            <a:off x="548640" y="6080188"/>
+            <a:ext cx="3429000" cy="201168"/>
+          </a:xfrm>
+          <a:prstGeom prst="rect">
+            <a:avLst/>
+          </a:prstGeom>
+          <a:noFill/>
+        </p:spPr>
+        <p:txBody>
+          <a:bodyPr wrap="square" anchor="t" lIns="0" rIns="0" tIns="0" bIns="0">
+            <a:spAutoFit/>
+          </a:bodyPr>
+          <a:lstStyle/>
+          <a:p>
+            <a:pPr algn="ctr"/>
+            <a:r>
+              <a:rPr sz="1000" b="0">
+                <a:solidFill>
+                  <a:srgbClr val="8B97AA"/>
+                </a:solidFill>
+                <a:latin typeface="Pretendard"/>
+              </a:rPr>
+              <a:t>③ 점수 분해</a:t>
+            </a:r>
+          </a:p>
+        </p:txBody>
+      </p:sp>
+      <p:pic>
+        <p:nvPicPr>
+          <p:cNvPr id="12" name="Picture 11" descr="shot_07_jsonld.png"/>
+          <p:cNvPicPr>
+            <a:picLocks noChangeAspect="1"/>
+          </p:cNvPicPr>
+          <p:nvPr/>
+        </p:nvPicPr>
+        <p:blipFill>
+          <a:blip r:embed="rId5"/>
+          <a:stretch>
+            <a:fillRect/>
+          </a:stretch>
+        </p:blipFill>
+        <p:spPr>
+          <a:xfrm>
+            <a:off x="4069080" y="4114800"/>
+            <a:ext cx="3429000" cy="1928812"/>
+          </a:xfrm>
+          <a:prstGeom prst="rect">
+            <a:avLst/>
+          </a:prstGeom>
+        </p:spPr>
+      </p:pic>
+      <p:sp>
+        <p:nvSpPr>
+          <p:cNvPr id="13" name="TextBox 12"/>
+          <p:cNvSpPr txBox="1"/>
+          <p:nvPr/>
+        </p:nvSpPr>
+        <p:spPr>
+          <a:xfrm>
+            <a:off x="4069080" y="6080188"/>
+            <a:ext cx="3429000" cy="201168"/>
+          </a:xfrm>
+          <a:prstGeom prst="rect">
+            <a:avLst/>
+          </a:prstGeom>
+          <a:noFill/>
+        </p:spPr>
+        <p:txBody>
+          <a:bodyPr wrap="square" anchor="t" lIns="0" rIns="0" tIns="0" bIns="0">
+            <a:spAutoFit/>
+          </a:bodyPr>
+          <a:lstStyle/>
+          <a:p>
+            <a:pPr algn="ctr"/>
+            <a:r>
+              <a:rPr sz="1000" b="0">
+                <a:solidFill>
+                  <a:srgbClr val="8B97AA"/>
+                </a:solidFill>
+                <a:latin typeface="Pretendard"/>
+              </a:rPr>
+              <a:t>④ JSON-LD 발행</a:t>
+            </a:r>
+          </a:p>
+        </p:txBody>
+      </p:sp>
+      <p:sp>
+        <p:nvSpPr>
+          <p:cNvPr id="14" name="TextBox 13"/>
           <p:cNvSpPr txBox="1"/>
           <p:nvPr/>
         </p:nvSpPr>
@@ -7807,7 +8019,7 @@
       </p:sp>
       <p:sp>
         <p:nvSpPr>
-          <p:cNvPr id="8" name="Rectangle 7"/>
+          <p:cNvPr id="15" name="Rectangle 14"/>
           <p:cNvSpPr/>
           <p:nvPr/>
         </p:nvSpPr>
@@ -7850,7 +8062,7 @@
       </p:sp>
       <p:sp>
         <p:nvSpPr>
-          <p:cNvPr id="9" name="TextBox 8"/>
+          <p:cNvPr id="16" name="TextBox 15"/>
           <p:cNvSpPr txBox="1"/>
           <p:nvPr/>
         </p:nvSpPr>
@@ -7885,7 +8097,7 @@
       </p:sp>
       <p:sp>
         <p:nvSpPr>
-          <p:cNvPr id="10" name="Rectangle 9"/>
+          <p:cNvPr id="17" name="Rectangle 16"/>
           <p:cNvSpPr/>
           <p:nvPr/>
         </p:nvSpPr>
@@ -7928,7 +8140,7 @@
       </p:sp>
       <p:sp>
         <p:nvSpPr>
-          <p:cNvPr id="11" name="TextBox 10"/>
+          <p:cNvPr id="18" name="TextBox 17"/>
           <p:cNvSpPr txBox="1"/>
           <p:nvPr/>
         </p:nvSpPr>
@@ -7963,7 +8175,7 @@
       </p:sp>
       <p:sp>
         <p:nvSpPr>
-          <p:cNvPr id="12" name="Rectangle 11"/>
+          <p:cNvPr id="19" name="Rectangle 18"/>
           <p:cNvSpPr/>
           <p:nvPr/>
         </p:nvSpPr>
@@ -8006,7 +8218,7 @@
       </p:sp>
       <p:sp>
         <p:nvSpPr>
-          <p:cNvPr id="13" name="TextBox 12"/>
+          <p:cNvPr id="20" name="TextBox 19"/>
           <p:cNvSpPr txBox="1"/>
           <p:nvPr/>
         </p:nvSpPr>
@@ -8041,7 +8253,7 @@
       </p:sp>
       <p:sp>
         <p:nvSpPr>
-          <p:cNvPr id="14" name="Rectangle 13"/>
+          <p:cNvPr id="21" name="Rectangle 20"/>
           <p:cNvSpPr/>
           <p:nvPr/>
         </p:nvSpPr>
@@ -8084,7 +8296,7 @@
       </p:sp>
       <p:sp>
         <p:nvSpPr>
-          <p:cNvPr id="15" name="TextBox 14"/>
+          <p:cNvPr id="22" name="TextBox 21"/>
           <p:cNvSpPr txBox="1"/>
           <p:nvPr/>
         </p:nvSpPr>
@@ -8119,7 +8331,7 @@
       </p:sp>
       <p:sp>
         <p:nvSpPr>
-          <p:cNvPr id="16" name="Rectangle 15"/>
+          <p:cNvPr id="23" name="Rectangle 22"/>
           <p:cNvSpPr/>
           <p:nvPr/>
         </p:nvSpPr>
@@ -8162,7 +8374,7 @@
       </p:sp>
       <p:sp>
         <p:nvSpPr>
-          <p:cNvPr id="17" name="TextBox 16"/>
+          <p:cNvPr id="24" name="TextBox 23"/>
           <p:cNvSpPr txBox="1"/>
           <p:nvPr/>
         </p:nvSpPr>
@@ -8197,7 +8409,7 @@
       </p:sp>
       <p:sp>
         <p:nvSpPr>
-          <p:cNvPr id="18" name="TextBox 17"/>
+          <p:cNvPr id="25" name="TextBox 24"/>
           <p:cNvSpPr txBox="1"/>
           <p:nvPr/>
         </p:nvSpPr>
@@ -8232,7 +8444,7 @@
       </p:sp>
       <p:sp>
         <p:nvSpPr>
-          <p:cNvPr id="19" name="TextBox 18"/>
+          <p:cNvPr id="26" name="TextBox 25"/>
           <p:cNvSpPr txBox="1"/>
           <p:nvPr/>
         </p:nvSpPr>

</xml_diff>